<commit_message>
Regenerate PPTX files with latest content changes
- slides-simple-animated.pptx: Slidev export with --with-clicks (one slide
  per animation step, 11MB, visually faithful)
- slides-simple-editable.pptx: python-pptx editable version (50KB)
- generate_pptx.py: sync all content changes (landscape 6 cards, badge
  translations, limiting factor blocks, Two Concepts, IBM Cloud,
  Chrome Dev Tools, USB port heading, application templating)

Co-Authored-By: Claude Sonnet 4.6 <noreply@anthropic.com>
</commit_message>
<xml_diff>
--- a/slides-simple-editable.pptx
+++ b/slides-simple-editable.pptx
@@ -3798,7 +3798,7 @@
                 </a:solidFill>
                 <a:latin typeface="Calibri"/>
               </a:rPr>
-              <a:t>📝</a:t>
+              <a:t>📐</a:t>
             </a:r>
           </a:p>
         </p:txBody>
@@ -3833,7 +3833,7 @@
                 </a:solidFill>
                 <a:latin typeface="Calibri"/>
               </a:rPr>
-              <a:t>Meeting recap</a:t>
+              <a:t>Application templating</a:t>
             </a:r>
           </a:p>
         </p:txBody>
@@ -3868,7 +3868,7 @@
                 </a:solidFill>
                 <a:latin typeface="Calibri"/>
               </a:rPr>
-              <a:t>"Summarize this meeting" → Structured recap with decisions, action items, and owners — ready to share.</a:t>
+              <a:t>"Bootstrap a new microservice" → Generates the full project structure following company standards: architecture, naming, CI config, README.</a:t>
             </a:r>
           </a:p>
         </p:txBody>
@@ -7067,7 +7067,7 @@
                 </a:solidFill>
                 <a:latin typeface="Calibri"/>
               </a:rPr>
-              <a:t>The Landscape</a:t>
+              <a:t>Landscape Overview</a:t>
             </a:r>
           </a:p>
         </p:txBody>
@@ -7080,8 +7080,379 @@
         </p:nvSpPr>
         <p:spPr>
           <a:xfrm>
-            <a:off x="320040" y="914400"/>
-            <a:ext cx="2103120" cy="4754880"/>
+            <a:off x="365760" y="914400"/>
+            <a:ext cx="3657600" cy="2560320"/>
+          </a:xfrm>
+          <a:prstGeom prst="rect">
+            <a:avLst/>
+          </a:prstGeom>
+          <a:solidFill>
+            <a:srgbClr val="FFF8F0"/>
+          </a:solidFill>
+          <a:ln w="19050">
+            <a:solidFill>
+              <a:srgbClr val="D97706"/>
+            </a:solidFill>
+          </a:ln>
+        </p:spPr>
+        <p:style>
+          <a:lnRef idx="1">
+            <a:schemeClr val="accent1"/>
+          </a:lnRef>
+          <a:fillRef idx="3">
+            <a:schemeClr val="accent1"/>
+          </a:fillRef>
+          <a:effectRef idx="2">
+            <a:schemeClr val="accent1"/>
+          </a:effectRef>
+          <a:fontRef idx="minor">
+            <a:schemeClr val="lt1"/>
+          </a:fontRef>
+        </p:style>
+        <p:txBody>
+          <a:bodyPr rtlCol="0" anchor="ctr"/>
+          <a:lstStyle/>
+          <a:p>
+            <a:pPr algn="ctr"/>
+          </a:p>
+        </p:txBody>
+      </p:sp>
+      <p:sp>
+        <p:nvSpPr>
+          <p:cNvPr id="5" name="TextBox 4"/>
+          <p:cNvSpPr txBox="1"/>
+          <p:nvPr/>
+        </p:nvSpPr>
+        <p:spPr>
+          <a:xfrm>
+            <a:off x="502920" y="1024128"/>
+            <a:ext cx="3383280" cy="502920"/>
+          </a:xfrm>
+          <a:prstGeom prst="rect">
+            <a:avLst/>
+          </a:prstGeom>
+          <a:noFill/>
+        </p:spPr>
+        <p:txBody>
+          <a:bodyPr wrap="square">
+            <a:spAutoFit/>
+          </a:bodyPr>
+          <a:lstStyle/>
+          <a:p>
+            <a:pPr algn="l"/>
+            <a:r>
+              <a:rPr sz="1300" b="1" i="0">
+                <a:solidFill>
+                  <a:srgbClr val="1A1A2E"/>
+                </a:solidFill>
+                <a:latin typeface="Calibri"/>
+              </a:rPr>
+              <a:t>🤖  Claude Code
+→ Claude Cowork</a:t>
+            </a:r>
+          </a:p>
+        </p:txBody>
+      </p:sp>
+      <p:sp>
+        <p:nvSpPr>
+          <p:cNvPr id="6" name="TextBox 5"/>
+          <p:cNvSpPr txBox="1"/>
+          <p:nvPr/>
+        </p:nvSpPr>
+        <p:spPr>
+          <a:xfrm>
+            <a:off x="502920" y="1536192"/>
+            <a:ext cx="3383280" cy="228600"/>
+          </a:xfrm>
+          <a:prstGeom prst="rect">
+            <a:avLst/>
+          </a:prstGeom>
+          <a:noFill/>
+        </p:spPr>
+        <p:txBody>
+          <a:bodyPr wrap="square">
+            <a:spAutoFit/>
+          </a:bodyPr>
+          <a:lstStyle/>
+          <a:p>
+            <a:pPr algn="l"/>
+            <a:r>
+              <a:rPr sz="1000" b="0" i="0">
+                <a:solidFill>
+                  <a:srgbClr val="888888"/>
+                </a:solidFill>
+                <a:latin typeface="Calibri"/>
+              </a:rPr>
+              <a:t>Anthropic</a:t>
+            </a:r>
+          </a:p>
+        </p:txBody>
+      </p:sp>
+      <p:sp>
+        <p:nvSpPr>
+          <p:cNvPr id="7" name="TextBox 6"/>
+          <p:cNvSpPr txBox="1"/>
+          <p:nvPr/>
+        </p:nvSpPr>
+        <p:spPr>
+          <a:xfrm>
+            <a:off x="502920" y="1783080"/>
+            <a:ext cx="3383280" cy="1188720"/>
+          </a:xfrm>
+          <a:prstGeom prst="rect">
+            <a:avLst/>
+          </a:prstGeom>
+          <a:noFill/>
+        </p:spPr>
+        <p:txBody>
+          <a:bodyPr wrap="square">
+            <a:spAutoFit/>
+          </a:bodyPr>
+          <a:lstStyle/>
+          <a:p>
+            <a:pPr algn="l"/>
+            <a:r>
+              <a:rPr sz="1000" b="0" i="0">
+                <a:solidFill>
+                  <a:srgbClr val="1A1A2E"/>
+                </a:solidFill>
+                <a:latin typeface="Calibri"/>
+              </a:rPr>
+              <a:t>The first agentic tool. Cowork born when non-devs started using it — packaged for teams &amp; entities.</a:t>
+            </a:r>
+          </a:p>
+        </p:txBody>
+      </p:sp>
+      <p:sp>
+        <p:nvSpPr>
+          <p:cNvPr id="8" name="TextBox 7"/>
+          <p:cNvSpPr txBox="1"/>
+          <p:nvPr/>
+        </p:nvSpPr>
+        <p:spPr>
+          <a:xfrm>
+            <a:off x="502920" y="3063240"/>
+            <a:ext cx="3383280" cy="320040"/>
+          </a:xfrm>
+          <a:prstGeom prst="rect">
+            <a:avLst/>
+          </a:prstGeom>
+          <a:noFill/>
+        </p:spPr>
+        <p:txBody>
+          <a:bodyPr wrap="square">
+            <a:spAutoFit/>
+          </a:bodyPr>
+          <a:lstStyle/>
+          <a:p>
+            <a:pPr algn="l"/>
+            <a:r>
+              <a:rPr sz="1000" b="1" i="0">
+                <a:solidFill>
+                  <a:srgbClr val="D97706"/>
+                </a:solidFill>
+                <a:latin typeface="Calibri"/>
+              </a:rPr>
+              <a:t>🔄 negotiation in progress</a:t>
+            </a:r>
+          </a:p>
+        </p:txBody>
+      </p:sp>
+      <p:sp>
+        <p:nvSpPr>
+          <p:cNvPr id="9" name="Rectangle 8"/>
+          <p:cNvSpPr/>
+          <p:nvPr/>
+        </p:nvSpPr>
+        <p:spPr>
+          <a:xfrm>
+            <a:off x="4343399" y="914400"/>
+            <a:ext cx="3657600" cy="2560320"/>
+          </a:xfrm>
+          <a:prstGeom prst="rect">
+            <a:avLst/>
+          </a:prstGeom>
+          <a:solidFill>
+            <a:srgbClr val="F8F9FA"/>
+          </a:solidFill>
+          <a:ln w="19050">
+            <a:solidFill>
+              <a:srgbClr val="64748B"/>
+            </a:solidFill>
+          </a:ln>
+        </p:spPr>
+        <p:style>
+          <a:lnRef idx="1">
+            <a:schemeClr val="accent1"/>
+          </a:lnRef>
+          <a:fillRef idx="3">
+            <a:schemeClr val="accent1"/>
+          </a:fillRef>
+          <a:effectRef idx="2">
+            <a:schemeClr val="accent1"/>
+          </a:effectRef>
+          <a:fontRef idx="minor">
+            <a:schemeClr val="lt1"/>
+          </a:fontRef>
+        </p:style>
+        <p:txBody>
+          <a:bodyPr rtlCol="0" anchor="ctr"/>
+          <a:lstStyle/>
+          <a:p>
+            <a:pPr algn="ctr"/>
+          </a:p>
+        </p:txBody>
+      </p:sp>
+      <p:sp>
+        <p:nvSpPr>
+          <p:cNvPr id="10" name="TextBox 9"/>
+          <p:cNvSpPr txBox="1"/>
+          <p:nvPr/>
+        </p:nvSpPr>
+        <p:spPr>
+          <a:xfrm>
+            <a:off x="4480559" y="1024128"/>
+            <a:ext cx="3383280" cy="502920"/>
+          </a:xfrm>
+          <a:prstGeom prst="rect">
+            <a:avLst/>
+          </a:prstGeom>
+          <a:noFill/>
+        </p:spPr>
+        <p:txBody>
+          <a:bodyPr wrap="square">
+            <a:spAutoFit/>
+          </a:bodyPr>
+          <a:lstStyle/>
+          <a:p>
+            <a:pPr algn="l"/>
+            <a:r>
+              <a:rPr sz="1300" b="1" i="0">
+                <a:solidFill>
+                  <a:srgbClr val="1A1A2E"/>
+                </a:solidFill>
+                <a:latin typeface="Calibri"/>
+              </a:rPr>
+              <a:t>🧠  Codex</a:t>
+            </a:r>
+          </a:p>
+        </p:txBody>
+      </p:sp>
+      <p:sp>
+        <p:nvSpPr>
+          <p:cNvPr id="11" name="TextBox 10"/>
+          <p:cNvSpPr txBox="1"/>
+          <p:nvPr/>
+        </p:nvSpPr>
+        <p:spPr>
+          <a:xfrm>
+            <a:off x="4480559" y="1536192"/>
+            <a:ext cx="3383280" cy="228600"/>
+          </a:xfrm>
+          <a:prstGeom prst="rect">
+            <a:avLst/>
+          </a:prstGeom>
+          <a:noFill/>
+        </p:spPr>
+        <p:txBody>
+          <a:bodyPr wrap="square">
+            <a:spAutoFit/>
+          </a:bodyPr>
+          <a:lstStyle/>
+          <a:p>
+            <a:pPr algn="l"/>
+            <a:r>
+              <a:rPr sz="1000" b="0" i="0">
+                <a:solidFill>
+                  <a:srgbClr val="888888"/>
+                </a:solidFill>
+                <a:latin typeface="Calibri"/>
+              </a:rPr>
+              <a:t>OpenAI</a:t>
+            </a:r>
+          </a:p>
+        </p:txBody>
+      </p:sp>
+      <p:sp>
+        <p:nvSpPr>
+          <p:cNvPr id="12" name="TextBox 11"/>
+          <p:cNvSpPr txBox="1"/>
+          <p:nvPr/>
+        </p:nvSpPr>
+        <p:spPr>
+          <a:xfrm>
+            <a:off x="4480559" y="1783080"/>
+            <a:ext cx="3383280" cy="1188720"/>
+          </a:xfrm>
+          <a:prstGeom prst="rect">
+            <a:avLst/>
+          </a:prstGeom>
+          <a:noFill/>
+        </p:spPr>
+        <p:txBody>
+          <a:bodyPr wrap="square">
+            <a:spAutoFit/>
+          </a:bodyPr>
+          <a:lstStyle/>
+          <a:p>
+            <a:pPr algn="l"/>
+            <a:r>
+              <a:rPr sz="1000" b="0" i="0">
+                <a:solidFill>
+                  <a:srgbClr val="1A1A2E"/>
+                </a:solidFill>
+                <a:latin typeface="Calibri"/>
+              </a:rPr>
+              <a:t>Unified CLI + open-source option — two strong bets from OpenAI.</a:t>
+            </a:r>
+          </a:p>
+        </p:txBody>
+      </p:sp>
+      <p:sp>
+        <p:nvSpPr>
+          <p:cNvPr id="13" name="TextBox 12"/>
+          <p:cNvSpPr txBox="1"/>
+          <p:nvPr/>
+        </p:nvSpPr>
+        <p:spPr>
+          <a:xfrm>
+            <a:off x="4480559" y="3063240"/>
+            <a:ext cx="3383280" cy="320040"/>
+          </a:xfrm>
+          <a:prstGeom prst="rect">
+            <a:avLst/>
+          </a:prstGeom>
+          <a:noFill/>
+        </p:spPr>
+        <p:txBody>
+          <a:bodyPr wrap="square">
+            <a:spAutoFit/>
+          </a:bodyPr>
+          <a:lstStyle/>
+          <a:p>
+            <a:pPr algn="l"/>
+            <a:r>
+              <a:rPr sz="1000" b="1" i="0">
+                <a:solidFill>
+                  <a:srgbClr val="64748B"/>
+                </a:solidFill>
+                <a:latin typeface="Calibri"/>
+              </a:rPr>
+              <a:t>✗ not available</a:t>
+            </a:r>
+          </a:p>
+        </p:txBody>
+      </p:sp>
+      <p:sp>
+        <p:nvSpPr>
+          <p:cNvPr id="14" name="Rectangle 13"/>
+          <p:cNvSpPr/>
+          <p:nvPr/>
+        </p:nvSpPr>
+        <p:spPr>
+          <a:xfrm>
+            <a:off x="8321038" y="914400"/>
+            <a:ext cx="3657600" cy="2560320"/>
           </a:xfrm>
           <a:prstGeom prst="rect">
             <a:avLst/>
@@ -7119,98 +7490,432 @@
       </p:sp>
       <p:sp>
         <p:nvSpPr>
-          <p:cNvPr id="5" name="TextBox 4"/>
-          <p:cNvSpPr txBox="1"/>
-          <p:nvPr/>
-        </p:nvSpPr>
-        <p:spPr>
-          <a:xfrm>
-            <a:off x="320040" y="1051560"/>
-            <a:ext cx="2103120" cy="457200"/>
-          </a:xfrm>
-          <a:prstGeom prst="rect">
-            <a:avLst/>
-          </a:prstGeom>
-          <a:noFill/>
-        </p:spPr>
-        <p:txBody>
-          <a:bodyPr wrap="square">
-            <a:spAutoFit/>
-          </a:bodyPr>
+          <p:cNvPr id="15" name="TextBox 14"/>
+          <p:cNvSpPr txBox="1"/>
+          <p:nvPr/>
+        </p:nvSpPr>
+        <p:spPr>
+          <a:xfrm>
+            <a:off x="8458198" y="1024128"/>
+            <a:ext cx="3383280" cy="502920"/>
+          </a:xfrm>
+          <a:prstGeom prst="rect">
+            <a:avLst/>
+          </a:prstGeom>
+          <a:noFill/>
+        </p:spPr>
+        <p:txBody>
+          <a:bodyPr wrap="square">
+            <a:spAutoFit/>
+          </a:bodyPr>
+          <a:lstStyle/>
+          <a:p>
+            <a:pPr algn="l"/>
+            <a:r>
+              <a:rPr sz="1300" b="1" i="0">
+                <a:solidFill>
+                  <a:srgbClr val="1A1A2E"/>
+                </a:solidFill>
+                <a:latin typeface="Calibri"/>
+              </a:rPr>
+              <a:t>🌊  Mistral Vibe</a:t>
+            </a:r>
+          </a:p>
+        </p:txBody>
+      </p:sp>
+      <p:sp>
+        <p:nvSpPr>
+          <p:cNvPr id="16" name="TextBox 15"/>
+          <p:cNvSpPr txBox="1"/>
+          <p:nvPr/>
+        </p:nvSpPr>
+        <p:spPr>
+          <a:xfrm>
+            <a:off x="8458198" y="1536192"/>
+            <a:ext cx="3383280" cy="228600"/>
+          </a:xfrm>
+          <a:prstGeom prst="rect">
+            <a:avLst/>
+          </a:prstGeom>
+          <a:noFill/>
+        </p:spPr>
+        <p:txBody>
+          <a:bodyPr wrap="square">
+            <a:spAutoFit/>
+          </a:bodyPr>
+          <a:lstStyle/>
+          <a:p>
+            <a:pPr algn="l"/>
+            <a:r>
+              <a:rPr sz="1000" b="0" i="0">
+                <a:solidFill>
+                  <a:srgbClr val="888888"/>
+                </a:solidFill>
+                <a:latin typeface="Calibri"/>
+              </a:rPr>
+              <a:t>Mistral</a:t>
+            </a:r>
+          </a:p>
+        </p:txBody>
+      </p:sp>
+      <p:sp>
+        <p:nvSpPr>
+          <p:cNvPr id="17" name="TextBox 16"/>
+          <p:cNvSpPr txBox="1"/>
+          <p:nvPr/>
+        </p:nvSpPr>
+        <p:spPr>
+          <a:xfrm>
+            <a:off x="8458198" y="1783080"/>
+            <a:ext cx="3383280" cy="1188720"/>
+          </a:xfrm>
+          <a:prstGeom prst="rect">
+            <a:avLst/>
+          </a:prstGeom>
+          <a:noFill/>
+        </p:spPr>
+        <p:txBody>
+          <a:bodyPr wrap="square">
+            <a:spAutoFit/>
+          </a:bodyPr>
+          <a:lstStyle/>
+          <a:p>
+            <a:pPr algn="l"/>
+            <a:r>
+              <a:rPr sz="1000" b="0" i="0">
+                <a:solidFill>
+                  <a:srgbClr val="1A1A2E"/>
+                </a:solidFill>
+                <a:latin typeface="Calibri"/>
+              </a:rPr>
+              <a:t>Our strategic partner's agentic tool.</a:t>
+            </a:r>
+          </a:p>
+        </p:txBody>
+      </p:sp>
+      <p:sp>
+        <p:nvSpPr>
+          <p:cNvPr id="18" name="TextBox 17"/>
+          <p:cNvSpPr txBox="1"/>
+          <p:nvPr/>
+        </p:nvSpPr>
+        <p:spPr>
+          <a:xfrm>
+            <a:off x="8458198" y="3063240"/>
+            <a:ext cx="3383280" cy="320040"/>
+          </a:xfrm>
+          <a:prstGeom prst="rect">
+            <a:avLst/>
+          </a:prstGeom>
+          <a:noFill/>
+        </p:spPr>
+        <p:txBody>
+          <a:bodyPr wrap="square">
+            <a:spAutoFit/>
+          </a:bodyPr>
+          <a:lstStyle/>
+          <a:p>
+            <a:pPr algn="l"/>
+            <a:r>
+              <a:rPr sz="1000" b="1" i="0">
+                <a:solidFill>
+                  <a:srgbClr val="009C6D"/>
+                </a:solidFill>
+                <a:latin typeface="Calibri"/>
+              </a:rPr>
+              <a:t>✓ available</a:t>
+            </a:r>
+          </a:p>
+        </p:txBody>
+      </p:sp>
+      <p:sp>
+        <p:nvSpPr>
+          <p:cNvPr id="19" name="Rectangle 18"/>
+          <p:cNvSpPr/>
+          <p:nvPr/>
+        </p:nvSpPr>
+        <p:spPr>
+          <a:xfrm>
+            <a:off x="365760" y="3703320"/>
+            <a:ext cx="3657600" cy="2560320"/>
+          </a:xfrm>
+          <a:prstGeom prst="rect">
+            <a:avLst/>
+          </a:prstGeom>
+          <a:solidFill>
+            <a:srgbClr val="FFF8F0"/>
+          </a:solidFill>
+          <a:ln w="19050">
+            <a:solidFill>
+              <a:srgbClr val="D97706"/>
+            </a:solidFill>
+          </a:ln>
+        </p:spPr>
+        <p:style>
+          <a:lnRef idx="1">
+            <a:schemeClr val="accent1"/>
+          </a:lnRef>
+          <a:fillRef idx="3">
+            <a:schemeClr val="accent1"/>
+          </a:fillRef>
+          <a:effectRef idx="2">
+            <a:schemeClr val="accent1"/>
+          </a:effectRef>
+          <a:fontRef idx="minor">
+            <a:schemeClr val="lt1"/>
+          </a:fontRef>
+        </p:style>
+        <p:txBody>
+          <a:bodyPr rtlCol="0" anchor="ctr"/>
           <a:lstStyle/>
           <a:p>
             <a:pPr algn="ctr"/>
-            <a:r>
-              <a:rPr sz="2200" b="0" i="0">
+          </a:p>
+        </p:txBody>
+      </p:sp>
+      <p:sp>
+        <p:nvSpPr>
+          <p:cNvPr id="20" name="TextBox 19"/>
+          <p:cNvSpPr txBox="1"/>
+          <p:nvPr/>
+        </p:nvSpPr>
+        <p:spPr>
+          <a:xfrm>
+            <a:off x="502920" y="3813048"/>
+            <a:ext cx="3383280" cy="502920"/>
+          </a:xfrm>
+          <a:prstGeom prst="rect">
+            <a:avLst/>
+          </a:prstGeom>
+          <a:noFill/>
+        </p:spPr>
+        <p:txBody>
+          <a:bodyPr wrap="square">
+            <a:spAutoFit/>
+          </a:bodyPr>
+          <a:lstStyle/>
+          <a:p>
+            <a:pPr algn="l"/>
+            <a:r>
+              <a:rPr sz="1300" b="1" i="0">
                 <a:solidFill>
                   <a:srgbClr val="1A1A2E"/>
                 </a:solidFill>
                 <a:latin typeface="Calibri"/>
               </a:rPr>
-              <a:t>🤖</a:t>
-            </a:r>
-          </a:p>
-        </p:txBody>
-      </p:sp>
-      <p:sp>
-        <p:nvSpPr>
-          <p:cNvPr id="6" name="TextBox 5"/>
-          <p:cNvSpPr txBox="1"/>
-          <p:nvPr/>
-        </p:nvSpPr>
-        <p:spPr>
-          <a:xfrm>
-            <a:off x="411480" y="1508760"/>
-            <a:ext cx="1920240" cy="548640"/>
-          </a:xfrm>
-          <a:prstGeom prst="rect">
-            <a:avLst/>
-          </a:prstGeom>
-          <a:noFill/>
-        </p:spPr>
-        <p:txBody>
-          <a:bodyPr wrap="square">
-            <a:spAutoFit/>
-          </a:bodyPr>
+              <a:t>🏢  IBM Bob</a:t>
+            </a:r>
+          </a:p>
+        </p:txBody>
+      </p:sp>
+      <p:sp>
+        <p:nvSpPr>
+          <p:cNvPr id="21" name="TextBox 20"/>
+          <p:cNvSpPr txBox="1"/>
+          <p:nvPr/>
+        </p:nvSpPr>
+        <p:spPr>
+          <a:xfrm>
+            <a:off x="502920" y="4325112"/>
+            <a:ext cx="3383280" cy="228600"/>
+          </a:xfrm>
+          <a:prstGeom prst="rect">
+            <a:avLst/>
+          </a:prstGeom>
+          <a:noFill/>
+        </p:spPr>
+        <p:txBody>
+          <a:bodyPr wrap="square">
+            <a:spAutoFit/>
+          </a:bodyPr>
+          <a:lstStyle/>
+          <a:p>
+            <a:pPr algn="l"/>
+            <a:r>
+              <a:rPr sz="1000" b="0" i="0">
+                <a:solidFill>
+                  <a:srgbClr val="888888"/>
+                </a:solidFill>
+                <a:latin typeface="Calibri"/>
+              </a:rPr>
+              <a:t>IBM</a:t>
+            </a:r>
+          </a:p>
+        </p:txBody>
+      </p:sp>
+      <p:sp>
+        <p:nvSpPr>
+          <p:cNvPr id="22" name="TextBox 21"/>
+          <p:cNvSpPr txBox="1"/>
+          <p:nvPr/>
+        </p:nvSpPr>
+        <p:spPr>
+          <a:xfrm>
+            <a:off x="502920" y="4572000"/>
+            <a:ext cx="3383280" cy="1188720"/>
+          </a:xfrm>
+          <a:prstGeom prst="rect">
+            <a:avLst/>
+          </a:prstGeom>
+          <a:noFill/>
+        </p:spPr>
+        <p:txBody>
+          <a:bodyPr wrap="square">
+            <a:spAutoFit/>
+          </a:bodyPr>
+          <a:lstStyle/>
+          <a:p>
+            <a:pPr algn="l"/>
+            <a:r>
+              <a:rPr sz="1000" b="0" i="0">
+                <a:solidFill>
+                  <a:srgbClr val="1A1A2E"/>
+                </a:solidFill>
+                <a:latin typeface="Calibri"/>
+              </a:rPr>
+              <a:t>Experimentation currently underway internally.</a:t>
+            </a:r>
+          </a:p>
+        </p:txBody>
+      </p:sp>
+      <p:sp>
+        <p:nvSpPr>
+          <p:cNvPr id="23" name="TextBox 22"/>
+          <p:cNvSpPr txBox="1"/>
+          <p:nvPr/>
+        </p:nvSpPr>
+        <p:spPr>
+          <a:xfrm>
+            <a:off x="502920" y="5852160"/>
+            <a:ext cx="3383280" cy="320040"/>
+          </a:xfrm>
+          <a:prstGeom prst="rect">
+            <a:avLst/>
+          </a:prstGeom>
+          <a:noFill/>
+        </p:spPr>
+        <p:txBody>
+          <a:bodyPr wrap="square">
+            <a:spAutoFit/>
+          </a:bodyPr>
+          <a:lstStyle/>
+          <a:p>
+            <a:pPr algn="l"/>
+            <a:r>
+              <a:rPr sz="1000" b="1" i="0">
+                <a:solidFill>
+                  <a:srgbClr val="D97706"/>
+                </a:solidFill>
+                <a:latin typeface="Calibri"/>
+              </a:rPr>
+              <a:t>🧪 experimentation in progress</a:t>
+            </a:r>
+          </a:p>
+        </p:txBody>
+      </p:sp>
+      <p:sp>
+        <p:nvSpPr>
+          <p:cNvPr id="24" name="Rectangle 23"/>
+          <p:cNvSpPr/>
+          <p:nvPr/>
+        </p:nvSpPr>
+        <p:spPr>
+          <a:xfrm>
+            <a:off x="4343399" y="3703320"/>
+            <a:ext cx="3657600" cy="2560320"/>
+          </a:xfrm>
+          <a:prstGeom prst="rect">
+            <a:avLst/>
+          </a:prstGeom>
+          <a:solidFill>
+            <a:srgbClr val="F0FBF6"/>
+          </a:solidFill>
+          <a:ln w="19050">
+            <a:solidFill>
+              <a:srgbClr val="009C6D"/>
+            </a:solidFill>
+          </a:ln>
+        </p:spPr>
+        <p:style>
+          <a:lnRef idx="1">
+            <a:schemeClr val="accent1"/>
+          </a:lnRef>
+          <a:fillRef idx="3">
+            <a:schemeClr val="accent1"/>
+          </a:fillRef>
+          <a:effectRef idx="2">
+            <a:schemeClr val="accent1"/>
+          </a:effectRef>
+          <a:fontRef idx="minor">
+            <a:schemeClr val="lt1"/>
+          </a:fontRef>
+        </p:style>
+        <p:txBody>
+          <a:bodyPr rtlCol="0" anchor="ctr"/>
           <a:lstStyle/>
           <a:p>
             <a:pPr algn="ctr"/>
-            <a:r>
-              <a:rPr sz="1200" b="1" i="0">
+          </a:p>
+        </p:txBody>
+      </p:sp>
+      <p:sp>
+        <p:nvSpPr>
+          <p:cNvPr id="25" name="TextBox 24"/>
+          <p:cNvSpPr txBox="1"/>
+          <p:nvPr/>
+        </p:nvSpPr>
+        <p:spPr>
+          <a:xfrm>
+            <a:off x="4480559" y="3813048"/>
+            <a:ext cx="3383280" cy="502920"/>
+          </a:xfrm>
+          <a:prstGeom prst="rect">
+            <a:avLst/>
+          </a:prstGeom>
+          <a:noFill/>
+        </p:spPr>
+        <p:txBody>
+          <a:bodyPr wrap="square">
+            <a:spAutoFit/>
+          </a:bodyPr>
+          <a:lstStyle/>
+          <a:p>
+            <a:pPr algn="l"/>
+            <a:r>
+              <a:rPr sz="1300" b="1" i="0">
                 <a:solidFill>
                   <a:srgbClr val="1A1A2E"/>
                 </a:solidFill>
                 <a:latin typeface="Calibri"/>
               </a:rPr>
-              <a:t>Claude Code
-→ Claude Cowork</a:t>
-            </a:r>
-          </a:p>
-        </p:txBody>
-      </p:sp>
-      <p:sp>
-        <p:nvSpPr>
-          <p:cNvPr id="7" name="TextBox 6"/>
-          <p:cNvSpPr txBox="1"/>
-          <p:nvPr/>
-        </p:nvSpPr>
-        <p:spPr>
-          <a:xfrm>
-            <a:off x="411480" y="2103120"/>
-            <a:ext cx="1920240" cy="274320"/>
-          </a:xfrm>
-          <a:prstGeom prst="rect">
-            <a:avLst/>
-          </a:prstGeom>
-          <a:noFill/>
-        </p:spPr>
-        <p:txBody>
-          <a:bodyPr wrap="square">
-            <a:spAutoFit/>
-          </a:bodyPr>
-          <a:lstStyle/>
-          <a:p>
-            <a:pPr algn="ctr"/>
+              <a:t>⚙️  opencode</a:t>
+            </a:r>
+          </a:p>
+        </p:txBody>
+      </p:sp>
+      <p:sp>
+        <p:nvSpPr>
+          <p:cNvPr id="26" name="TextBox 25"/>
+          <p:cNvSpPr txBox="1"/>
+          <p:nvPr/>
+        </p:nvSpPr>
+        <p:spPr>
+          <a:xfrm>
+            <a:off x="4480559" y="4325112"/>
+            <a:ext cx="3383280" cy="228600"/>
+          </a:xfrm>
+          <a:prstGeom prst="rect">
+            <a:avLst/>
+          </a:prstGeom>
+          <a:noFill/>
+        </p:spPr>
+        <p:txBody>
+          <a:bodyPr wrap="square">
+            <a:spAutoFit/>
+          </a:bodyPr>
+          <a:lstStyle/>
+          <a:p>
+            <a:pPr algn="l"/>
             <a:r>
               <a:rPr sz="1000" b="0" i="0">
                 <a:solidFill>
@@ -7218,34 +7923,34 @@
                 </a:solidFill>
                 <a:latin typeface="Calibri"/>
               </a:rPr>
-              <a:t>Anthropic</a:t>
-            </a:r>
-          </a:p>
-        </p:txBody>
-      </p:sp>
-      <p:sp>
-        <p:nvSpPr>
-          <p:cNvPr id="8" name="TextBox 7"/>
-          <p:cNvSpPr txBox="1"/>
-          <p:nvPr/>
-        </p:nvSpPr>
-        <p:spPr>
-          <a:xfrm>
-            <a:off x="411480" y="2423160"/>
-            <a:ext cx="1920240" cy="2011680"/>
-          </a:xfrm>
-          <a:prstGeom prst="rect">
-            <a:avLst/>
-          </a:prstGeom>
-          <a:noFill/>
-        </p:spPr>
-        <p:txBody>
-          <a:bodyPr wrap="square">
-            <a:spAutoFit/>
-          </a:bodyPr>
-          <a:lstStyle/>
-          <a:p>
-            <a:pPr algn="ctr"/>
+              <a:t>Open source</a:t>
+            </a:r>
+          </a:p>
+        </p:txBody>
+      </p:sp>
+      <p:sp>
+        <p:nvSpPr>
+          <p:cNvPr id="27" name="TextBox 26"/>
+          <p:cNvSpPr txBox="1"/>
+          <p:nvPr/>
+        </p:nvSpPr>
+        <p:spPr>
+          <a:xfrm>
+            <a:off x="4480559" y="4572000"/>
+            <a:ext cx="3383280" cy="1188720"/>
+          </a:xfrm>
+          <a:prstGeom prst="rect">
+            <a:avLst/>
+          </a:prstGeom>
+          <a:noFill/>
+        </p:spPr>
+        <p:txBody>
+          <a:bodyPr wrap="square">
+            <a:spAutoFit/>
+          </a:bodyPr>
+          <a:lstStyle/>
+          <a:p>
+            <a:pPr algn="l"/>
             <a:r>
               <a:rPr sz="1000" b="0" i="0">
                 <a:solidFill>
@@ -7253,34 +7958,34 @@
                 </a:solidFill>
                 <a:latin typeface="Calibri"/>
               </a:rPr>
-              <a:t>The first agentic tool. Cowork born when non-devs started using it — packaged for teams &amp; entities.</a:t>
-            </a:r>
-          </a:p>
-        </p:txBody>
-      </p:sp>
-      <p:sp>
-        <p:nvSpPr>
-          <p:cNvPr id="9" name="TextBox 8"/>
-          <p:cNvSpPr txBox="1"/>
-          <p:nvPr/>
-        </p:nvSpPr>
-        <p:spPr>
-          <a:xfrm>
-            <a:off x="411480" y="4480560"/>
-            <a:ext cx="1920240" cy="320040"/>
-          </a:xfrm>
-          <a:prstGeom prst="rect">
-            <a:avLst/>
-          </a:prstGeom>
-          <a:noFill/>
-        </p:spPr>
-        <p:txBody>
-          <a:bodyPr wrap="square">
-            <a:spAutoFit/>
-          </a:bodyPr>
-          <a:lstStyle/>
-          <a:p>
-            <a:pPr algn="ctr"/>
+              <a:t>Most popular open-source agentic tool. Huge community ecosystem.</a:t>
+            </a:r>
+          </a:p>
+        </p:txBody>
+      </p:sp>
+      <p:sp>
+        <p:nvSpPr>
+          <p:cNvPr id="28" name="TextBox 27"/>
+          <p:cNvSpPr txBox="1"/>
+          <p:nvPr/>
+        </p:nvSpPr>
+        <p:spPr>
+          <a:xfrm>
+            <a:off x="4480559" y="5852160"/>
+            <a:ext cx="3383280" cy="320040"/>
+          </a:xfrm>
+          <a:prstGeom prst="rect">
+            <a:avLst/>
+          </a:prstGeom>
+          <a:noFill/>
+        </p:spPr>
+        <p:txBody>
+          <a:bodyPr wrap="square">
+            <a:spAutoFit/>
+          </a:bodyPr>
+          <a:lstStyle/>
+          <a:p>
+            <a:pPr algn="l"/>
             <a:r>
               <a:rPr sz="1000" b="1" i="0">
                 <a:solidFill>
@@ -7295,14 +8000,14 @@
       </p:sp>
       <p:sp>
         <p:nvSpPr>
-          <p:cNvPr id="10" name="Rectangle 9"/>
+          <p:cNvPr id="29" name="Rectangle 28"/>
           <p:cNvSpPr/>
           <p:nvPr/>
         </p:nvSpPr>
         <p:spPr>
           <a:xfrm>
-            <a:off x="2660904" y="914400"/>
-            <a:ext cx="2103120" cy="4754880"/>
+            <a:off x="8321038" y="3703320"/>
+            <a:ext cx="3657600" cy="2560320"/>
           </a:xfrm>
           <a:prstGeom prst="rect">
             <a:avLst/>
@@ -7340,167 +8045,132 @@
       </p:sp>
       <p:sp>
         <p:nvSpPr>
-          <p:cNvPr id="11" name="TextBox 10"/>
-          <p:cNvSpPr txBox="1"/>
-          <p:nvPr/>
-        </p:nvSpPr>
-        <p:spPr>
-          <a:xfrm>
-            <a:off x="2660904" y="1051560"/>
-            <a:ext cx="2103120" cy="457200"/>
-          </a:xfrm>
-          <a:prstGeom prst="rect">
-            <a:avLst/>
-          </a:prstGeom>
-          <a:noFill/>
-        </p:spPr>
-        <p:txBody>
-          <a:bodyPr wrap="square">
-            <a:spAutoFit/>
-          </a:bodyPr>
-          <a:lstStyle/>
-          <a:p>
-            <a:pPr algn="ctr"/>
-            <a:r>
-              <a:rPr sz="2200" b="0" i="0">
+          <p:cNvPr id="30" name="TextBox 29"/>
+          <p:cNvSpPr txBox="1"/>
+          <p:nvPr/>
+        </p:nvSpPr>
+        <p:spPr>
+          <a:xfrm>
+            <a:off x="8458198" y="3813048"/>
+            <a:ext cx="3383280" cy="502920"/>
+          </a:xfrm>
+          <a:prstGeom prst="rect">
+            <a:avLst/>
+          </a:prstGeom>
+          <a:noFill/>
+        </p:spPr>
+        <p:txBody>
+          <a:bodyPr wrap="square">
+            <a:spAutoFit/>
+          </a:bodyPr>
+          <a:lstStyle/>
+          <a:p>
+            <a:pPr algn="l"/>
+            <a:r>
+              <a:rPr sz="1300" b="1" i="0">
                 <a:solidFill>
                   <a:srgbClr val="1A1A2E"/>
                 </a:solidFill>
                 <a:latin typeface="Calibri"/>
               </a:rPr>
-              <a:t>🧠</a:t>
-            </a:r>
-          </a:p>
-        </p:txBody>
-      </p:sp>
-      <p:sp>
-        <p:nvSpPr>
-          <p:cNvPr id="12" name="TextBox 11"/>
-          <p:cNvSpPr txBox="1"/>
-          <p:nvPr/>
-        </p:nvSpPr>
-        <p:spPr>
-          <a:xfrm>
-            <a:off x="2752344" y="1508760"/>
-            <a:ext cx="1920240" cy="548640"/>
-          </a:xfrm>
-          <a:prstGeom prst="rect">
-            <a:avLst/>
-          </a:prstGeom>
-          <a:noFill/>
-        </p:spPr>
-        <p:txBody>
-          <a:bodyPr wrap="square">
-            <a:spAutoFit/>
-          </a:bodyPr>
-          <a:lstStyle/>
-          <a:p>
-            <a:pPr algn="ctr"/>
-            <a:r>
-              <a:rPr sz="1200" b="1" i="0">
+              <a:t>➕  And many more…</a:t>
+            </a:r>
+          </a:p>
+        </p:txBody>
+      </p:sp>
+      <p:sp>
+        <p:nvSpPr>
+          <p:cNvPr id="31" name="TextBox 30"/>
+          <p:cNvSpPr txBox="1"/>
+          <p:nvPr/>
+        </p:nvSpPr>
+        <p:spPr>
+          <a:xfrm>
+            <a:off x="8458198" y="4325112"/>
+            <a:ext cx="3383280" cy="228600"/>
+          </a:xfrm>
+          <a:prstGeom prst="rect">
+            <a:avLst/>
+          </a:prstGeom>
+          <a:noFill/>
+        </p:spPr>
+        <p:txBody>
+          <a:bodyPr wrap="square">
+            <a:spAutoFit/>
+          </a:bodyPr>
+          <a:lstStyle/>
+          <a:p>
+            <a:pPr algn="l"/>
+            <a:r>
+              <a:rPr sz="1000" b="0" i="0">
+                <a:solidFill>
+                  <a:srgbClr val="888888"/>
+                </a:solidFill>
+                <a:latin typeface="Calibri"/>
+              </a:rPr>
+              <a:t>Community &amp; Big Tech</a:t>
+            </a:r>
+          </a:p>
+        </p:txBody>
+      </p:sp>
+      <p:sp>
+        <p:nvSpPr>
+          <p:cNvPr id="32" name="TextBox 31"/>
+          <p:cNvSpPr txBox="1"/>
+          <p:nvPr/>
+        </p:nvSpPr>
+        <p:spPr>
+          <a:xfrm>
+            <a:off x="8458198" y="4572000"/>
+            <a:ext cx="3383280" cy="1188720"/>
+          </a:xfrm>
+          <a:prstGeom prst="rect">
+            <a:avLst/>
+          </a:prstGeom>
+          <a:noFill/>
+        </p:spPr>
+        <p:txBody>
+          <a:bodyPr wrap="square">
+            <a:spAutoFit/>
+          </a:bodyPr>
+          <a:lstStyle/>
+          <a:p>
+            <a:pPr algn="l"/>
+            <a:r>
+              <a:rPr sz="1000" b="0" i="0">
                 <a:solidFill>
                   <a:srgbClr val="1A1A2E"/>
                 </a:solidFill>
                 <a:latin typeface="Calibri"/>
               </a:rPr>
-              <a:t>Codex</a:t>
-            </a:r>
-          </a:p>
-        </p:txBody>
-      </p:sp>
-      <p:sp>
-        <p:nvSpPr>
-          <p:cNvPr id="13" name="TextBox 12"/>
-          <p:cNvSpPr txBox="1"/>
-          <p:nvPr/>
-        </p:nvSpPr>
-        <p:spPr>
-          <a:xfrm>
-            <a:off x="2752344" y="2103120"/>
-            <a:ext cx="1920240" cy="274320"/>
-          </a:xfrm>
-          <a:prstGeom prst="rect">
-            <a:avLst/>
-          </a:prstGeom>
-          <a:noFill/>
-        </p:spPr>
-        <p:txBody>
-          <a:bodyPr wrap="square">
-            <a:spAutoFit/>
-          </a:bodyPr>
-          <a:lstStyle/>
-          <a:p>
-            <a:pPr algn="ctr"/>
-            <a:r>
-              <a:rPr sz="1000" b="0" i="0">
-                <a:solidFill>
-                  <a:srgbClr val="888888"/>
-                </a:solidFill>
-                <a:latin typeface="Calibri"/>
-              </a:rPr>
-              <a:t>OpenAI</a:t>
-            </a:r>
-          </a:p>
-        </p:txBody>
-      </p:sp>
-      <p:sp>
-        <p:nvSpPr>
-          <p:cNvPr id="14" name="TextBox 13"/>
-          <p:cNvSpPr txBox="1"/>
-          <p:nvPr/>
-        </p:nvSpPr>
-        <p:spPr>
-          <a:xfrm>
-            <a:off x="2752344" y="2423160"/>
-            <a:ext cx="1920240" cy="2011680"/>
-          </a:xfrm>
-          <a:prstGeom prst="rect">
-            <a:avLst/>
-          </a:prstGeom>
-          <a:noFill/>
-        </p:spPr>
-        <p:txBody>
-          <a:bodyPr wrap="square">
-            <a:spAutoFit/>
-          </a:bodyPr>
-          <a:lstStyle/>
-          <a:p>
-            <a:pPr algn="ctr"/>
-            <a:r>
-              <a:rPr sz="1000" b="0" i="0">
-                <a:solidFill>
-                  <a:srgbClr val="1A1A2E"/>
-                </a:solidFill>
-                <a:latin typeface="Calibri"/>
-              </a:rPr>
-              <a:t>Unified CLI + open-source option — two strong bets from OpenAI.</a:t>
-            </a:r>
-          </a:p>
-        </p:txBody>
-      </p:sp>
-      <p:sp>
-        <p:nvSpPr>
-          <p:cNvPr id="15" name="TextBox 14"/>
-          <p:cNvSpPr txBox="1"/>
-          <p:nvPr/>
-        </p:nvSpPr>
-        <p:spPr>
-          <a:xfrm>
-            <a:off x="2752344" y="4480560"/>
-            <a:ext cx="1920240" cy="320040"/>
-          </a:xfrm>
-          <a:prstGeom prst="rect">
-            <a:avLst/>
-          </a:prstGeom>
-          <a:noFill/>
-        </p:spPr>
-        <p:txBody>
-          <a:bodyPr wrap="square">
-            <a:spAutoFit/>
-          </a:bodyPr>
-          <a:lstStyle/>
-          <a:p>
-            <a:pPr algn="ctr"/>
+              <a:t>Gemini CLI (Google), Continue (VS Code), OpenClaude, Amp, Cline, Cursor, Windsurf…</a:t>
+            </a:r>
+          </a:p>
+        </p:txBody>
+      </p:sp>
+      <p:sp>
+        <p:nvSpPr>
+          <p:cNvPr id="33" name="TextBox 32"/>
+          <p:cNvSpPr txBox="1"/>
+          <p:nvPr/>
+        </p:nvSpPr>
+        <p:spPr>
+          <a:xfrm>
+            <a:off x="8458198" y="5852160"/>
+            <a:ext cx="3383280" cy="320040"/>
+          </a:xfrm>
+          <a:prstGeom prst="rect">
+            <a:avLst/>
+          </a:prstGeom>
+          <a:noFill/>
+        </p:spPr>
+        <p:txBody>
+          <a:bodyPr wrap="square">
+            <a:spAutoFit/>
+          </a:bodyPr>
+          <a:lstStyle/>
+          <a:p>
+            <a:pPr algn="l"/>
             <a:r>
               <a:rPr sz="1000" b="1" i="0">
                 <a:solidFill>
@@ -7508,667 +8178,7 @@
                 </a:solidFill>
                 <a:latin typeface="Calibri"/>
               </a:rPr>
-              <a:t>✗ not available</a:t>
-            </a:r>
-          </a:p>
-        </p:txBody>
-      </p:sp>
-      <p:sp>
-        <p:nvSpPr>
-          <p:cNvPr id="16" name="Rectangle 15"/>
-          <p:cNvSpPr/>
-          <p:nvPr/>
-        </p:nvSpPr>
-        <p:spPr>
-          <a:xfrm>
-            <a:off x="5001768" y="914400"/>
-            <a:ext cx="2103120" cy="4754880"/>
-          </a:xfrm>
-          <a:prstGeom prst="rect">
-            <a:avLst/>
-          </a:prstGeom>
-          <a:solidFill>
-            <a:srgbClr val="F0FBF6"/>
-          </a:solidFill>
-          <a:ln w="19050">
-            <a:solidFill>
-              <a:srgbClr val="009C6D"/>
-            </a:solidFill>
-          </a:ln>
-        </p:spPr>
-        <p:style>
-          <a:lnRef idx="1">
-            <a:schemeClr val="accent1"/>
-          </a:lnRef>
-          <a:fillRef idx="3">
-            <a:schemeClr val="accent1"/>
-          </a:fillRef>
-          <a:effectRef idx="2">
-            <a:schemeClr val="accent1"/>
-          </a:effectRef>
-          <a:fontRef idx="minor">
-            <a:schemeClr val="lt1"/>
-          </a:fontRef>
-        </p:style>
-        <p:txBody>
-          <a:bodyPr rtlCol="0" anchor="ctr"/>
-          <a:lstStyle/>
-          <a:p>
-            <a:pPr algn="ctr"/>
-          </a:p>
-        </p:txBody>
-      </p:sp>
-      <p:sp>
-        <p:nvSpPr>
-          <p:cNvPr id="17" name="TextBox 16"/>
-          <p:cNvSpPr txBox="1"/>
-          <p:nvPr/>
-        </p:nvSpPr>
-        <p:spPr>
-          <a:xfrm>
-            <a:off x="5001768" y="1051560"/>
-            <a:ext cx="2103120" cy="457200"/>
-          </a:xfrm>
-          <a:prstGeom prst="rect">
-            <a:avLst/>
-          </a:prstGeom>
-          <a:noFill/>
-        </p:spPr>
-        <p:txBody>
-          <a:bodyPr wrap="square">
-            <a:spAutoFit/>
-          </a:bodyPr>
-          <a:lstStyle/>
-          <a:p>
-            <a:pPr algn="ctr"/>
-            <a:r>
-              <a:rPr sz="2200" b="0" i="0">
-                <a:solidFill>
-                  <a:srgbClr val="1A1A2E"/>
-                </a:solidFill>
-                <a:latin typeface="Calibri"/>
-              </a:rPr>
-              <a:t>🌊</a:t>
-            </a:r>
-          </a:p>
-        </p:txBody>
-      </p:sp>
-      <p:sp>
-        <p:nvSpPr>
-          <p:cNvPr id="18" name="TextBox 17"/>
-          <p:cNvSpPr txBox="1"/>
-          <p:nvPr/>
-        </p:nvSpPr>
-        <p:spPr>
-          <a:xfrm>
-            <a:off x="5093208" y="1508760"/>
-            <a:ext cx="1920240" cy="548640"/>
-          </a:xfrm>
-          <a:prstGeom prst="rect">
-            <a:avLst/>
-          </a:prstGeom>
-          <a:noFill/>
-        </p:spPr>
-        <p:txBody>
-          <a:bodyPr wrap="square">
-            <a:spAutoFit/>
-          </a:bodyPr>
-          <a:lstStyle/>
-          <a:p>
-            <a:pPr algn="ctr"/>
-            <a:r>
-              <a:rPr sz="1200" b="1" i="0">
-                <a:solidFill>
-                  <a:srgbClr val="1A1A2E"/>
-                </a:solidFill>
-                <a:latin typeface="Calibri"/>
-              </a:rPr>
-              <a:t>Mistral Vibe</a:t>
-            </a:r>
-          </a:p>
-        </p:txBody>
-      </p:sp>
-      <p:sp>
-        <p:nvSpPr>
-          <p:cNvPr id="19" name="TextBox 18"/>
-          <p:cNvSpPr txBox="1"/>
-          <p:nvPr/>
-        </p:nvSpPr>
-        <p:spPr>
-          <a:xfrm>
-            <a:off x="5093208" y="2103120"/>
-            <a:ext cx="1920240" cy="274320"/>
-          </a:xfrm>
-          <a:prstGeom prst="rect">
-            <a:avLst/>
-          </a:prstGeom>
-          <a:noFill/>
-        </p:spPr>
-        <p:txBody>
-          <a:bodyPr wrap="square">
-            <a:spAutoFit/>
-          </a:bodyPr>
-          <a:lstStyle/>
-          <a:p>
-            <a:pPr algn="ctr"/>
-            <a:r>
-              <a:rPr sz="1000" b="0" i="0">
-                <a:solidFill>
-                  <a:srgbClr val="888888"/>
-                </a:solidFill>
-                <a:latin typeface="Calibri"/>
-              </a:rPr>
-              <a:t>Mistral</a:t>
-            </a:r>
-          </a:p>
-        </p:txBody>
-      </p:sp>
-      <p:sp>
-        <p:nvSpPr>
-          <p:cNvPr id="20" name="TextBox 19"/>
-          <p:cNvSpPr txBox="1"/>
-          <p:nvPr/>
-        </p:nvSpPr>
-        <p:spPr>
-          <a:xfrm>
-            <a:off x="5093208" y="2423160"/>
-            <a:ext cx="1920240" cy="2011680"/>
-          </a:xfrm>
-          <a:prstGeom prst="rect">
-            <a:avLst/>
-          </a:prstGeom>
-          <a:noFill/>
-        </p:spPr>
-        <p:txBody>
-          <a:bodyPr wrap="square">
-            <a:spAutoFit/>
-          </a:bodyPr>
-          <a:lstStyle/>
-          <a:p>
-            <a:pPr algn="ctr"/>
-            <a:r>
-              <a:rPr sz="1000" b="0" i="0">
-                <a:solidFill>
-                  <a:srgbClr val="1A1A2E"/>
-                </a:solidFill>
-                <a:latin typeface="Calibri"/>
-              </a:rPr>
-              <a:t>Our strategic partner's agentic tool.</a:t>
-            </a:r>
-          </a:p>
-        </p:txBody>
-      </p:sp>
-      <p:sp>
-        <p:nvSpPr>
-          <p:cNvPr id="21" name="TextBox 20"/>
-          <p:cNvSpPr txBox="1"/>
-          <p:nvPr/>
-        </p:nvSpPr>
-        <p:spPr>
-          <a:xfrm>
-            <a:off x="5093208" y="4480560"/>
-            <a:ext cx="1920240" cy="320040"/>
-          </a:xfrm>
-          <a:prstGeom prst="rect">
-            <a:avLst/>
-          </a:prstGeom>
-          <a:noFill/>
-        </p:spPr>
-        <p:txBody>
-          <a:bodyPr wrap="square">
-            <a:spAutoFit/>
-          </a:bodyPr>
-          <a:lstStyle/>
-          <a:p>
-            <a:pPr algn="ctr"/>
-            <a:r>
-              <a:rPr sz="1000" b="1" i="0">
-                <a:solidFill>
-                  <a:srgbClr val="009C6D"/>
-                </a:solidFill>
-                <a:latin typeface="Calibri"/>
-              </a:rPr>
-              <a:t>✓ available</a:t>
-            </a:r>
-          </a:p>
-        </p:txBody>
-      </p:sp>
-      <p:sp>
-        <p:nvSpPr>
-          <p:cNvPr id="22" name="Rectangle 21"/>
-          <p:cNvSpPr/>
-          <p:nvPr/>
-        </p:nvSpPr>
-        <p:spPr>
-          <a:xfrm>
-            <a:off x="7342632" y="914400"/>
-            <a:ext cx="2103120" cy="4754880"/>
-          </a:xfrm>
-          <a:prstGeom prst="rect">
-            <a:avLst/>
-          </a:prstGeom>
-          <a:solidFill>
-            <a:srgbClr val="F8F9FA"/>
-          </a:solidFill>
-          <a:ln w="19050">
-            <a:solidFill>
-              <a:srgbClr val="D97706"/>
-            </a:solidFill>
-          </a:ln>
-        </p:spPr>
-        <p:style>
-          <a:lnRef idx="1">
-            <a:schemeClr val="accent1"/>
-          </a:lnRef>
-          <a:fillRef idx="3">
-            <a:schemeClr val="accent1"/>
-          </a:fillRef>
-          <a:effectRef idx="2">
-            <a:schemeClr val="accent1"/>
-          </a:effectRef>
-          <a:fontRef idx="minor">
-            <a:schemeClr val="lt1"/>
-          </a:fontRef>
-        </p:style>
-        <p:txBody>
-          <a:bodyPr rtlCol="0" anchor="ctr"/>
-          <a:lstStyle/>
-          <a:p>
-            <a:pPr algn="ctr"/>
-          </a:p>
-        </p:txBody>
-      </p:sp>
-      <p:sp>
-        <p:nvSpPr>
-          <p:cNvPr id="23" name="TextBox 22"/>
-          <p:cNvSpPr txBox="1"/>
-          <p:nvPr/>
-        </p:nvSpPr>
-        <p:spPr>
-          <a:xfrm>
-            <a:off x="7342632" y="1051560"/>
-            <a:ext cx="2103120" cy="457200"/>
-          </a:xfrm>
-          <a:prstGeom prst="rect">
-            <a:avLst/>
-          </a:prstGeom>
-          <a:noFill/>
-        </p:spPr>
-        <p:txBody>
-          <a:bodyPr wrap="square">
-            <a:spAutoFit/>
-          </a:bodyPr>
-          <a:lstStyle/>
-          <a:p>
-            <a:pPr algn="ctr"/>
-            <a:r>
-              <a:rPr sz="2200" b="0" i="0">
-                <a:solidFill>
-                  <a:srgbClr val="1A1A2E"/>
-                </a:solidFill>
-                <a:latin typeface="Calibri"/>
-              </a:rPr>
-              <a:t>🏢</a:t>
-            </a:r>
-          </a:p>
-        </p:txBody>
-      </p:sp>
-      <p:sp>
-        <p:nvSpPr>
-          <p:cNvPr id="24" name="TextBox 23"/>
-          <p:cNvSpPr txBox="1"/>
-          <p:nvPr/>
-        </p:nvSpPr>
-        <p:spPr>
-          <a:xfrm>
-            <a:off x="7434072" y="1508760"/>
-            <a:ext cx="1920240" cy="548640"/>
-          </a:xfrm>
-          <a:prstGeom prst="rect">
-            <a:avLst/>
-          </a:prstGeom>
-          <a:noFill/>
-        </p:spPr>
-        <p:txBody>
-          <a:bodyPr wrap="square">
-            <a:spAutoFit/>
-          </a:bodyPr>
-          <a:lstStyle/>
-          <a:p>
-            <a:pPr algn="ctr"/>
-            <a:r>
-              <a:rPr sz="1200" b="1" i="0">
-                <a:solidFill>
-                  <a:srgbClr val="1A1A2E"/>
-                </a:solidFill>
-                <a:latin typeface="Calibri"/>
-              </a:rPr>
-              <a:t>IBM Bob</a:t>
-            </a:r>
-          </a:p>
-        </p:txBody>
-      </p:sp>
-      <p:sp>
-        <p:nvSpPr>
-          <p:cNvPr id="25" name="TextBox 24"/>
-          <p:cNvSpPr txBox="1"/>
-          <p:nvPr/>
-        </p:nvSpPr>
-        <p:spPr>
-          <a:xfrm>
-            <a:off x="7434072" y="2103120"/>
-            <a:ext cx="1920240" cy="274320"/>
-          </a:xfrm>
-          <a:prstGeom prst="rect">
-            <a:avLst/>
-          </a:prstGeom>
-          <a:noFill/>
-        </p:spPr>
-        <p:txBody>
-          <a:bodyPr wrap="square">
-            <a:spAutoFit/>
-          </a:bodyPr>
-          <a:lstStyle/>
-          <a:p>
-            <a:pPr algn="ctr"/>
-            <a:r>
-              <a:rPr sz="1000" b="0" i="0">
-                <a:solidFill>
-                  <a:srgbClr val="888888"/>
-                </a:solidFill>
-                <a:latin typeface="Calibri"/>
-              </a:rPr>
-              <a:t>IBM</a:t>
-            </a:r>
-          </a:p>
-        </p:txBody>
-      </p:sp>
-      <p:sp>
-        <p:nvSpPr>
-          <p:cNvPr id="26" name="TextBox 25"/>
-          <p:cNvSpPr txBox="1"/>
-          <p:nvPr/>
-        </p:nvSpPr>
-        <p:spPr>
-          <a:xfrm>
-            <a:off x="7434072" y="2423160"/>
-            <a:ext cx="1920240" cy="2011680"/>
-          </a:xfrm>
-          <a:prstGeom prst="rect">
-            <a:avLst/>
-          </a:prstGeom>
-          <a:noFill/>
-        </p:spPr>
-        <p:txBody>
-          <a:bodyPr wrap="square">
-            <a:spAutoFit/>
-          </a:bodyPr>
-          <a:lstStyle/>
-          <a:p>
-            <a:pPr algn="ctr"/>
-            <a:r>
-              <a:rPr sz="1000" b="0" i="0">
-                <a:solidFill>
-                  <a:srgbClr val="1A1A2E"/>
-                </a:solidFill>
-                <a:latin typeface="Calibri"/>
-              </a:rPr>
-              <a:t>Currently in beta testing internally at BNP Paribas.</a:t>
-            </a:r>
-          </a:p>
-        </p:txBody>
-      </p:sp>
-      <p:sp>
-        <p:nvSpPr>
-          <p:cNvPr id="27" name="TextBox 26"/>
-          <p:cNvSpPr txBox="1"/>
-          <p:nvPr/>
-        </p:nvSpPr>
-        <p:spPr>
-          <a:xfrm>
-            <a:off x="7434072" y="4480560"/>
-            <a:ext cx="1920240" cy="320040"/>
-          </a:xfrm>
-          <a:prstGeom prst="rect">
-            <a:avLst/>
-          </a:prstGeom>
-          <a:noFill/>
-        </p:spPr>
-        <p:txBody>
-          <a:bodyPr wrap="square">
-            <a:spAutoFit/>
-          </a:bodyPr>
-          <a:lstStyle/>
-          <a:p>
-            <a:pPr algn="ctr"/>
-            <a:r>
-              <a:rPr sz="1000" b="1" i="0">
-                <a:solidFill>
-                  <a:srgbClr val="D97706"/>
-                </a:solidFill>
-                <a:latin typeface="Calibri"/>
-              </a:rPr>
-              <a:t>⚡ beta test</a:t>
-            </a:r>
-          </a:p>
-        </p:txBody>
-      </p:sp>
-      <p:sp>
-        <p:nvSpPr>
-          <p:cNvPr id="28" name="Rectangle 27"/>
-          <p:cNvSpPr/>
-          <p:nvPr/>
-        </p:nvSpPr>
-        <p:spPr>
-          <a:xfrm>
-            <a:off x="9683496" y="914400"/>
-            <a:ext cx="2103120" cy="4754880"/>
-          </a:xfrm>
-          <a:prstGeom prst="rect">
-            <a:avLst/>
-          </a:prstGeom>
-          <a:solidFill>
-            <a:srgbClr val="F0FBF6"/>
-          </a:solidFill>
-          <a:ln w="19050">
-            <a:solidFill>
-              <a:srgbClr val="009C6D"/>
-            </a:solidFill>
-          </a:ln>
-        </p:spPr>
-        <p:style>
-          <a:lnRef idx="1">
-            <a:schemeClr val="accent1"/>
-          </a:lnRef>
-          <a:fillRef idx="3">
-            <a:schemeClr val="accent1"/>
-          </a:fillRef>
-          <a:effectRef idx="2">
-            <a:schemeClr val="accent1"/>
-          </a:effectRef>
-          <a:fontRef idx="minor">
-            <a:schemeClr val="lt1"/>
-          </a:fontRef>
-        </p:style>
-        <p:txBody>
-          <a:bodyPr rtlCol="0" anchor="ctr"/>
-          <a:lstStyle/>
-          <a:p>
-            <a:pPr algn="ctr"/>
-          </a:p>
-        </p:txBody>
-      </p:sp>
-      <p:sp>
-        <p:nvSpPr>
-          <p:cNvPr id="29" name="TextBox 28"/>
-          <p:cNvSpPr txBox="1"/>
-          <p:nvPr/>
-        </p:nvSpPr>
-        <p:spPr>
-          <a:xfrm>
-            <a:off x="9683496" y="1051560"/>
-            <a:ext cx="2103120" cy="457200"/>
-          </a:xfrm>
-          <a:prstGeom prst="rect">
-            <a:avLst/>
-          </a:prstGeom>
-          <a:noFill/>
-        </p:spPr>
-        <p:txBody>
-          <a:bodyPr wrap="square">
-            <a:spAutoFit/>
-          </a:bodyPr>
-          <a:lstStyle/>
-          <a:p>
-            <a:pPr algn="ctr"/>
-            <a:r>
-              <a:rPr sz="2200" b="0" i="0">
-                <a:solidFill>
-                  <a:srgbClr val="1A1A2E"/>
-                </a:solidFill>
-                <a:latin typeface="Calibri"/>
-              </a:rPr>
-              <a:t>⚙️</a:t>
-            </a:r>
-          </a:p>
-        </p:txBody>
-      </p:sp>
-      <p:sp>
-        <p:nvSpPr>
-          <p:cNvPr id="30" name="TextBox 29"/>
-          <p:cNvSpPr txBox="1"/>
-          <p:nvPr/>
-        </p:nvSpPr>
-        <p:spPr>
-          <a:xfrm>
-            <a:off x="9774936" y="1508760"/>
-            <a:ext cx="1920240" cy="548640"/>
-          </a:xfrm>
-          <a:prstGeom prst="rect">
-            <a:avLst/>
-          </a:prstGeom>
-          <a:noFill/>
-        </p:spPr>
-        <p:txBody>
-          <a:bodyPr wrap="square">
-            <a:spAutoFit/>
-          </a:bodyPr>
-          <a:lstStyle/>
-          <a:p>
-            <a:pPr algn="ctr"/>
-            <a:r>
-              <a:rPr sz="1200" b="1" i="0">
-                <a:solidFill>
-                  <a:srgbClr val="1A1A2E"/>
-                </a:solidFill>
-                <a:latin typeface="Calibri"/>
-              </a:rPr>
-              <a:t>opencode</a:t>
-            </a:r>
-          </a:p>
-        </p:txBody>
-      </p:sp>
-      <p:sp>
-        <p:nvSpPr>
-          <p:cNvPr id="31" name="TextBox 30"/>
-          <p:cNvSpPr txBox="1"/>
-          <p:nvPr/>
-        </p:nvSpPr>
-        <p:spPr>
-          <a:xfrm>
-            <a:off x="9774936" y="2103120"/>
-            <a:ext cx="1920240" cy="274320"/>
-          </a:xfrm>
-          <a:prstGeom prst="rect">
-            <a:avLst/>
-          </a:prstGeom>
-          <a:noFill/>
-        </p:spPr>
-        <p:txBody>
-          <a:bodyPr wrap="square">
-            <a:spAutoFit/>
-          </a:bodyPr>
-          <a:lstStyle/>
-          <a:p>
-            <a:pPr algn="ctr"/>
-            <a:r>
-              <a:rPr sz="1000" b="0" i="0">
-                <a:solidFill>
-                  <a:srgbClr val="888888"/>
-                </a:solidFill>
-                <a:latin typeface="Calibri"/>
-              </a:rPr>
-              <a:t>Open source</a:t>
-            </a:r>
-          </a:p>
-        </p:txBody>
-      </p:sp>
-      <p:sp>
-        <p:nvSpPr>
-          <p:cNvPr id="32" name="TextBox 31"/>
-          <p:cNvSpPr txBox="1"/>
-          <p:nvPr/>
-        </p:nvSpPr>
-        <p:spPr>
-          <a:xfrm>
-            <a:off x="9774936" y="2423160"/>
-            <a:ext cx="1920240" cy="2011680"/>
-          </a:xfrm>
-          <a:prstGeom prst="rect">
-            <a:avLst/>
-          </a:prstGeom>
-          <a:noFill/>
-        </p:spPr>
-        <p:txBody>
-          <a:bodyPr wrap="square">
-            <a:spAutoFit/>
-          </a:bodyPr>
-          <a:lstStyle/>
-          <a:p>
-            <a:pPr algn="ctr"/>
-            <a:r>
-              <a:rPr sz="1000" b="0" i="0">
-                <a:solidFill>
-                  <a:srgbClr val="1A1A2E"/>
-                </a:solidFill>
-                <a:latin typeface="Calibri"/>
-              </a:rPr>
-              <a:t>Most popular open-source agentic tool. Huge community ecosystem.</a:t>
-            </a:r>
-          </a:p>
-        </p:txBody>
-      </p:sp>
-      <p:sp>
-        <p:nvSpPr>
-          <p:cNvPr id="33" name="TextBox 32"/>
-          <p:cNvSpPr txBox="1"/>
-          <p:nvPr/>
-        </p:nvSpPr>
-        <p:spPr>
-          <a:xfrm>
-            <a:off x="9774936" y="4480560"/>
-            <a:ext cx="1920240" cy="320040"/>
-          </a:xfrm>
-          <a:prstGeom prst="rect">
-            <a:avLst/>
-          </a:prstGeom>
-          <a:noFill/>
-        </p:spPr>
-        <p:txBody>
-          <a:bodyPr wrap="square">
-            <a:spAutoFit/>
-          </a:bodyPr>
-          <a:lstStyle/>
-          <a:p>
-            <a:pPr algn="ctr"/>
-            <a:r>
-              <a:rPr sz="1000" b="1" i="0">
-                <a:solidFill>
-                  <a:srgbClr val="009C6D"/>
-                </a:solidFill>
-                <a:latin typeface="Calibri"/>
-              </a:rPr>
-              <a:t>✓ available</a:t>
+              <a:t>ecosystem growing fast</a:t>
             </a:r>
           </a:p>
         </p:txBody>
@@ -8493,7 +8503,7 @@
                 </a:solidFill>
                 <a:latin typeface="Calibri"/>
               </a:rPr>
-              <a:t>✓  What the chassis brings</a:t>
+              <a:t>🚗  Chassis are now nearly feature-equivalent</a:t>
             </a:r>
           </a:p>
         </p:txBody>
@@ -8526,13 +8536,13 @@
               </a:spcBef>
             </a:pPr>
             <a:r>
-              <a:rPr sz="1400">
+              <a:rPr sz="1300">
                 <a:solidFill>
                   <a:srgbClr val="1A1A2E"/>
                 </a:solidFill>
                 <a:latin typeface="Calibri"/>
               </a:rPr>
-              <a:t>• File access &amp; editing</a:t>
+              <a:t>• All major tools read files, run commands, use MCP</a:t>
             </a:r>
           </a:p>
           <a:p>
@@ -8542,13 +8552,13 @@
               </a:spcBef>
             </a:pPr>
             <a:r>
-              <a:rPr sz="1400">
+              <a:rPr sz="1300">
                 <a:solidFill>
                   <a:srgbClr val="1A1A2E"/>
                 </a:solidFill>
                 <a:latin typeface="Calibri"/>
               </a:rPr>
-              <a:t>• Command execution</a:t>
+              <a:t>• Real differentiator: open source vs. closed source</a:t>
             </a:r>
           </a:p>
           <a:p>
@@ -8558,13 +8568,13 @@
               </a:spcBef>
             </a:pPr>
             <a:r>
-              <a:rPr sz="1400">
+              <a:rPr sz="1300">
                 <a:solidFill>
                   <a:srgbClr val="1A1A2E"/>
                 </a:solidFill>
                 <a:latin typeface="Calibri"/>
               </a:rPr>
-              <a:t>• Tool integrations (MCP)</a:t>
+              <a:t>• And popularity — community, plugins, integrations</a:t>
             </a:r>
           </a:p>
           <a:p>
@@ -8574,13 +8584,29 @@
               </a:spcBef>
             </a:pPr>
             <a:r>
-              <a:rPr sz="1400">
+              <a:rPr sz="1300">
                 <a:solidFill>
                   <a:srgbClr val="1A1A2E"/>
                 </a:solidFill>
                 <a:latin typeface="Calibri"/>
               </a:rPr>
-              <a:t>• Memory &amp; context management</a:t>
+              <a:t>• Some vendors use the chassis for post-training</a:t>
+            </a:r>
+          </a:p>
+          <a:p>
+            <a:pPr>
+              <a:spcBef>
+                <a:spcPts val="200"/>
+              </a:spcBef>
+            </a:pPr>
+            <a:r>
+              <a:rPr sz="1300">
+                <a:solidFill>
+                  <a:srgbClr val="1A1A2E"/>
+                </a:solidFill>
+                <a:latin typeface="Calibri"/>
+              </a:rPr>
+              <a:t>  (fine-tuning on real agentic tasks) — a growing edge</a:t>
             </a:r>
           </a:p>
         </p:txBody>
@@ -8659,7 +8685,7 @@
                 </a:solidFill>
                 <a:latin typeface="Calibri"/>
               </a:rPr>
-              <a:t>⚠️  What only the LLM can provide</a:t>
+              <a:t>⚠️  The engine gap: frontier vs. small models</a:t>
             </a:r>
           </a:p>
         </p:txBody>
@@ -8692,13 +8718,13 @@
               </a:spcBef>
             </a:pPr>
             <a:r>
-              <a:rPr sz="1400">
+              <a:rPr sz="1300">
                 <a:solidFill>
                   <a:srgbClr val="1A1A2E"/>
                 </a:solidFill>
                 <a:latin typeface="Calibri"/>
               </a:rPr>
-              <a:t>• Reasoning quality</a:t>
+              <a:t>• Frontier models — Claude Opus/Sonnet, GPT-5, Kimi:</a:t>
             </a:r>
           </a:p>
           <a:p>
@@ -8708,13 +8734,13 @@
               </a:spcBef>
             </a:pPr>
             <a:r>
-              <a:rPr sz="1400">
+              <a:rPr sz="1300">
                 <a:solidFill>
                   <a:srgbClr val="1A1A2E"/>
                 </a:solidFill>
                 <a:latin typeface="Calibri"/>
               </a:rPr>
-              <a:t>• Domain knowledge</a:t>
+              <a:t>  deep reasoning, large context, best results</a:t>
             </a:r>
           </a:p>
           <a:p>
@@ -8724,13 +8750,13 @@
               </a:spcBef>
             </a:pPr>
             <a:r>
-              <a:rPr sz="1400">
+              <a:rPr sz="1300">
                 <a:solidFill>
                   <a:srgbClr val="1A1A2E"/>
                 </a:solidFill>
                 <a:latin typeface="Calibri"/>
               </a:rPr>
-              <a:t>• Code correctness</a:t>
+              <a:t>• Small models — Gemma, Mistral Mini, GPT-OSS:</a:t>
             </a:r>
           </a:p>
           <a:p>
@@ -8740,13 +8766,45 @@
               </a:spcBef>
             </a:pPr>
             <a:r>
-              <a:rPr sz="1400">
+              <a:rPr sz="1300">
                 <a:solidFill>
                   <a:srgbClr val="1A1A2E"/>
                 </a:solidFill>
                 <a:latin typeface="Calibri"/>
               </a:rPr>
-              <a:t>• Avoiding hallucinations</a:t>
+              <a:t>  faster &amp; cheaper, but limited on complex tasks</a:t>
+            </a:r>
+          </a:p>
+          <a:p>
+            <a:pPr>
+              <a:spcBef>
+                <a:spcPts val="200"/>
+              </a:spcBef>
+            </a:pPr>
+            <a:r>
+              <a:rPr sz="1300">
+                <a:solidFill>
+                  <a:srgbClr val="1A1A2E"/>
+                </a:solidFill>
+                <a:latin typeface="Calibri"/>
+              </a:rPr>
+              <a:t>• Choosing the right model matters as much</a:t>
+            </a:r>
+          </a:p>
+          <a:p>
+            <a:pPr>
+              <a:spcBef>
+                <a:spcPts val="200"/>
+              </a:spcBef>
+            </a:pPr>
+            <a:r>
+              <a:rPr sz="1300">
+                <a:solidFill>
+                  <a:srgbClr val="1A1A2E"/>
+                </a:solidFill>
+                <a:latin typeface="Calibri"/>
+              </a:rPr>
+              <a:t>  as the chassis</a:t>
             </a:r>
           </a:p>
         </p:txBody>
@@ -8912,7 +8970,7 @@
                 </a:solidFill>
                 <a:latin typeface="Calibri"/>
               </a:rPr>
-              <a:t>Two Tools to Know</a:t>
+              <a:t>Two Concepts to Know</a:t>
             </a:r>
           </a:p>
         </p:txBody>
@@ -10030,7 +10088,7 @@
                 </a:solidFill>
                 <a:latin typeface="Calibri"/>
               </a:rPr>
-              <a:t>☁️ AWS</a:t>
+              <a:t>☁️ IBM Cloud</a:t>
             </a:r>
           </a:p>
         </p:txBody>
@@ -10260,7 +10318,7 @@
                 </a:solidFill>
                 <a:latin typeface="Calibri"/>
               </a:rPr>
-              <a:t>🎭 Playwright</a:t>
+              <a:t>🌐 Chrome Dev Tools</a:t>
             </a:r>
           </a:p>
         </p:txBody>
@@ -10330,7 +10388,7 @@
                 </a:solidFill>
                 <a:latin typeface="Calibri"/>
               </a:rPr>
-              <a:t>Why it matters</a:t>
+              <a:t>The USB port of AI Agents</a:t>
             </a:r>
           </a:p>
         </p:txBody>
@@ -10344,88 +10402,7 @@
         <p:spPr>
           <a:xfrm>
             <a:off x="6492240" y="1417320"/>
-            <a:ext cx="5120640" cy="1097280"/>
-          </a:xfrm>
-          <a:prstGeom prst="rect">
-            <a:avLst/>
-          </a:prstGeom>
-          <a:solidFill>
-            <a:srgbClr val="F0FBF6"/>
-          </a:solidFill>
-          <a:ln w="19050">
-            <a:solidFill>
-              <a:srgbClr val="009C6D"/>
-            </a:solidFill>
-          </a:ln>
-        </p:spPr>
-        <p:style>
-          <a:lnRef idx="1">
-            <a:schemeClr val="accent1"/>
-          </a:lnRef>
-          <a:fillRef idx="3">
-            <a:schemeClr val="accent1"/>
-          </a:fillRef>
-          <a:effectRef idx="2">
-            <a:schemeClr val="accent1"/>
-          </a:effectRef>
-          <a:fontRef idx="minor">
-            <a:schemeClr val="lt1"/>
-          </a:fontRef>
-        </p:style>
-        <p:txBody>
-          <a:bodyPr rtlCol="0" anchor="ctr"/>
-          <a:lstStyle/>
-          <a:p>
-            <a:pPr algn="ctr"/>
-          </a:p>
-        </p:txBody>
-      </p:sp>
-      <p:sp>
-        <p:nvSpPr>
-          <p:cNvPr id="22" name="TextBox 21"/>
-          <p:cNvSpPr txBox="1"/>
-          <p:nvPr/>
-        </p:nvSpPr>
-        <p:spPr>
-          <a:xfrm>
-            <a:off x="6629400" y="1508760"/>
-            <a:ext cx="4846320" cy="914400"/>
-          </a:xfrm>
-          <a:prstGeom prst="rect">
-            <a:avLst/>
-          </a:prstGeom>
-          <a:noFill/>
-        </p:spPr>
-        <p:txBody>
-          <a:bodyPr wrap="square">
-            <a:spAutoFit/>
-          </a:bodyPr>
-          <a:lstStyle/>
-          <a:p>
-            <a:pPr algn="l"/>
-            <a:r>
-              <a:rPr sz="1300" b="0" i="0">
-                <a:solidFill>
-                  <a:srgbClr val="1A1A2E"/>
-                </a:solidFill>
-                <a:latin typeface="Calibri"/>
-              </a:rPr>
-              <a:t>💡  No more copy-pasting data between tools.
-The AI reads and writes directly in your systems.</a:t>
-            </a:r>
-          </a:p>
-        </p:txBody>
-      </p:sp>
-      <p:sp>
-        <p:nvSpPr>
-          <p:cNvPr id="23" name="Rectangle 22"/>
-          <p:cNvSpPr/>
-          <p:nvPr/>
-        </p:nvSpPr>
-        <p:spPr>
-          <a:xfrm>
-            <a:off x="6492240" y="2743200"/>
-            <a:ext cx="5120640" cy="3291840"/>
+            <a:ext cx="5120640" cy="4572000"/>
           </a:xfrm>
           <a:prstGeom prst="rect">
             <a:avLst/>
@@ -10463,13 +10440,13 @@
       </p:sp>
       <p:sp>
         <p:nvSpPr>
-          <p:cNvPr id="24" name="TextBox 23"/>
-          <p:cNvSpPr txBox="1"/>
-          <p:nvPr/>
-        </p:nvSpPr>
-        <p:spPr>
-          <a:xfrm>
-            <a:off x="6629400" y="2852928"/>
+          <p:cNvPr id="22" name="TextBox 21"/>
+          <p:cNvSpPr txBox="1"/>
+          <p:nvPr/>
+        </p:nvSpPr>
+        <p:spPr>
+          <a:xfrm>
+            <a:off x="6629400" y="1527048"/>
             <a:ext cx="4846320" cy="365760"/>
           </a:xfrm>
           <a:prstGeom prst="rect">
@@ -10497,14 +10474,14 @@
       </p:sp>
       <p:sp>
         <p:nvSpPr>
-          <p:cNvPr id="25" name="TextBox 24"/>
-          <p:cNvSpPr txBox="1"/>
-          <p:nvPr/>
-        </p:nvSpPr>
-        <p:spPr>
-          <a:xfrm>
-            <a:off x="6629400" y="3246120"/>
-            <a:ext cx="4846320" cy="2697480"/>
+          <p:cNvPr id="23" name="TextBox 22"/>
+          <p:cNvSpPr txBox="1"/>
+          <p:nvPr/>
+        </p:nvSpPr>
+        <p:spPr>
+          <a:xfrm>
+            <a:off x="6629400" y="1920240"/>
+            <a:ext cx="4846320" cy="3977640"/>
           </a:xfrm>
           <a:prstGeom prst="rect">
             <a:avLst/>
@@ -10584,7 +10561,7 @@
       </p:sp>
       <p:sp>
         <p:nvSpPr>
-          <p:cNvPr id="26" name="TextBox 25"/>
+          <p:cNvPr id="24" name="TextBox 23"/>
           <p:cNvSpPr txBox="1"/>
           <p:nvPr/>
         </p:nvSpPr>

</xml_diff>